<commit_message>
Add degraded-image threshold result to report and slides
Co-Authored-By: Claude Sonnet 5.5 <noreply@anthropic.com>
</commit_message>
<xml_diff>
--- a/Mid_Semester_Presentation_Agentic_RAG_Digital_Forensics.pptx
+++ b/Mid_Semester_Presentation_Agentic_RAG_Digital_Forensics.pptx
@@ -4989,7 +4989,7 @@
                 <a:latin typeface="Arial"/>
                 <a:cs typeface="Arial"/>
               </a:rPr>
-              <a:t>Planned: a threshold tuned on degraded images.</a:t>
+              <a:t>A second threshold fitted on degraded calibration images halves false alarms on Celeb-DF (9% to 4%) and WildDeepfake (17% to 8%) for 2 to 4 points of fakes caught. FF++ stays at 37%.</a:t>
             </a:r>
           </a:p>
         </p:txBody>
@@ -5966,7 +5966,7 @@
                 <a:latin typeface="Arial"/>
                 <a:cs typeface="Arial"/>
               </a:rPr>
-              <a:t>Tune a threshold for re-uploaded images</a:t>
+              <a:t>Detect re-uploads and apply the degraded-image threshold</a:t>
             </a:r>
           </a:p>
           <a:p>

</xml_diff>